<commit_message>
mise a jour du cadrage et du branding
</commit_message>
<xml_diff>
--- a/cadrage/KWISMO_Presentation_Light.pptx
+++ b/cadrage/KWISMO_Presentation_Light.pptx
@@ -6062,8 +6062,8 @@
         </p:blipFill>
         <p:spPr>
           <a:xfrm>
-            <a:off x="502920" y="1327104"/>
-            <a:ext cx="9280000" cy="5219999"/>
+            <a:off x="502921" y="1327104"/>
+            <a:ext cx="9279998" cy="5219999"/>
           </a:xfrm>
           <a:prstGeom prst="rect">
             <a:avLst/>

</xml_diff>